<commit_message>
new dc data add
</commit_message>
<xml_diff>
--- a/burocracy/obsolete/gia2026/260611gia_ostapiv.pptx
+++ b/burocracy/obsolete/gia2026/260611gia_ostapiv.pptx
@@ -284,7 +284,7 @@
           <a:p>
             <a:fld id="{3CC69274-AE8F-42E7-BC20-9A03910CC1A3}" type="datetimeFigureOut">
               <a:rPr lang="ru-RU" smtClean="0"/>
-              <a:t>11.06.2026</a:t>
+              <a:t>19.08.2026</a:t>
             </a:fld>
             <a:endParaRPr lang="ru-RU"/>
           </a:p>
@@ -793,7 +793,7 @@
           <a:p>
             <a:fld id="{8B756801-B80C-452C-AD44-8DE8D95B4C70}" type="datetime1">
               <a:rPr lang="ru-RU" smtClean="0"/>
-              <a:t>11.06.2026</a:t>
+              <a:t>19.08.2026</a:t>
             </a:fld>
             <a:endParaRPr lang="ru-RU"/>
           </a:p>
@@ -991,7 +991,7 @@
           <a:p>
             <a:fld id="{8CEB96B3-126A-4206-833E-37399B35A634}" type="datetime1">
               <a:rPr lang="ru-RU" smtClean="0"/>
-              <a:t>11.06.2026</a:t>
+              <a:t>19.08.2026</a:t>
             </a:fld>
             <a:endParaRPr lang="ru-RU"/>
           </a:p>
@@ -1199,7 +1199,7 @@
           <a:p>
             <a:fld id="{95ACA5ED-B9D6-49D7-B49D-E92DB3C62077}" type="datetime1">
               <a:rPr lang="ru-RU" smtClean="0"/>
-              <a:t>11.06.2026</a:t>
+              <a:t>19.08.2026</a:t>
             </a:fld>
             <a:endParaRPr lang="ru-RU"/>
           </a:p>
@@ -1397,7 +1397,7 @@
           <a:p>
             <a:fld id="{AB8C7FF4-A2B2-4635-B94F-80742FD17F6E}" type="datetime1">
               <a:rPr lang="ru-RU" smtClean="0"/>
-              <a:t>11.06.2026</a:t>
+              <a:t>19.08.2026</a:t>
             </a:fld>
             <a:endParaRPr lang="ru-RU"/>
           </a:p>
@@ -1672,7 +1672,7 @@
           <a:p>
             <a:fld id="{9EDC4073-F696-4049-B323-219CBB8C36C6}" type="datetime1">
               <a:rPr lang="ru-RU" smtClean="0"/>
-              <a:t>11.06.2026</a:t>
+              <a:t>19.08.2026</a:t>
             </a:fld>
             <a:endParaRPr lang="ru-RU"/>
           </a:p>
@@ -1937,7 +1937,7 @@
           <a:p>
             <a:fld id="{F481C08D-9624-4422-83BB-369AC4B95C29}" type="datetime1">
               <a:rPr lang="ru-RU" smtClean="0"/>
-              <a:t>11.06.2026</a:t>
+              <a:t>19.08.2026</a:t>
             </a:fld>
             <a:endParaRPr lang="ru-RU"/>
           </a:p>
@@ -2349,7 +2349,7 @@
           <a:p>
             <a:fld id="{8DC69388-F088-4B20-A6EC-A0081E2D539C}" type="datetime1">
               <a:rPr lang="ru-RU" smtClean="0"/>
-              <a:t>11.06.2026</a:t>
+              <a:t>19.08.2026</a:t>
             </a:fld>
             <a:endParaRPr lang="ru-RU"/>
           </a:p>
@@ -2490,7 +2490,7 @@
           <a:p>
             <a:fld id="{845CC627-6147-4A8F-96B0-1FCCFC2244E6}" type="datetime1">
               <a:rPr lang="ru-RU" smtClean="0"/>
-              <a:t>11.06.2026</a:t>
+              <a:t>19.08.2026</a:t>
             </a:fld>
             <a:endParaRPr lang="ru-RU"/>
           </a:p>
@@ -2603,7 +2603,7 @@
           <a:p>
             <a:fld id="{303C3DDE-29B1-4365-8B04-F35C28D17772}" type="datetime1">
               <a:rPr lang="ru-RU" smtClean="0"/>
-              <a:t>11.06.2026</a:t>
+              <a:t>19.08.2026</a:t>
             </a:fld>
             <a:endParaRPr lang="ru-RU"/>
           </a:p>
@@ -2914,7 +2914,7 @@
           <a:p>
             <a:fld id="{11701F54-C889-480F-8A92-D28CB155834E}" type="datetime1">
               <a:rPr lang="ru-RU" smtClean="0"/>
-              <a:t>11.06.2026</a:t>
+              <a:t>19.08.2026</a:t>
             </a:fld>
             <a:endParaRPr lang="ru-RU"/>
           </a:p>
@@ -3202,7 +3202,7 @@
           <a:p>
             <a:fld id="{F51F6A7C-E8A3-4E67-8ACC-4BC83953C3B2}" type="datetime1">
               <a:rPr lang="ru-RU" smtClean="0"/>
-              <a:t>11.06.2026</a:t>
+              <a:t>19.08.2026</a:t>
             </a:fld>
             <a:endParaRPr lang="ru-RU"/>
           </a:p>
@@ -3443,7 +3443,7 @@
           <a:p>
             <a:fld id="{45854C59-B003-4E50-A257-5F9BB1FD6BE7}" type="datetime1">
               <a:rPr lang="ru-RU" smtClean="0"/>
-              <a:t>11.06.2026</a:t>
+              <a:t>19.08.2026</a:t>
             </a:fld>
             <a:endParaRPr lang="ru-RU"/>
           </a:p>
@@ -14287,7 +14287,7 @@
           <a:graphicData uri="http://schemas.openxmlformats.org/presentationml/2006/ole">
             <mc:AlternateContent xmlns:mc="http://schemas.openxmlformats.org/markup-compatibility/2006">
               <mc:Choice xmlns:v="urn:schemas-microsoft-com:vml" Requires="v">
-                <p:oleObj spid="_x0000_s5141" name="Equation" r:id="rId6" imgW="3124313" imgH="711746" progId="Equation.DSMT4">
+                <p:oleObj spid="_x0000_s5142" name="Equation" r:id="rId6" imgW="3124313" imgH="711746" progId="Equation.DSMT4">
                   <p:embed/>
                 </p:oleObj>
               </mc:Choice>

</xml_diff>